<commit_message>
Finale Anpassung vor Pitch NeoImpulse
</commit_message>
<xml_diff>
--- a/PowerPoint/WestLogiX_Pitch_neoimpulse.pptx
+++ b/PowerPoint/WestLogiX_Pitch_neoimpulse.pptx
@@ -5587,7 +5587,29 @@
                 <a:ea typeface="Calibri" pitchFamily="34" charset="-122"/>
                 <a:cs typeface="Calibri" pitchFamily="34" charset="-120"/>
               </a:rPr>
-              <a:t>Der Agent läuft lokal auf meinem Laptop und spricht direkt mit den Daten.</a:t>
+              <a:t>Der Agent läuft lokal auf </a:t>
+            </a:r>
+            <a:r>
+              <a:rPr lang="en-US" sz="1300" dirty="0" err="1">
+                <a:solidFill>
+                  <a:srgbClr val="4A6080"/>
+                </a:solidFill>
+                <a:latin typeface="Calibri" pitchFamily="34" charset="0"/>
+                <a:ea typeface="Calibri" pitchFamily="34" charset="-122"/>
+                <a:cs typeface="Calibri" pitchFamily="34" charset="-120"/>
+              </a:rPr>
+              <a:t>meinem</a:t>
+            </a:r>
+            <a:r>
+              <a:rPr lang="en-US" sz="1300" dirty="0">
+                <a:solidFill>
+                  <a:srgbClr val="4A6080"/>
+                </a:solidFill>
+                <a:latin typeface="Calibri" pitchFamily="34" charset="0"/>
+                <a:ea typeface="Calibri" pitchFamily="34" charset="-122"/>
+                <a:cs typeface="Calibri" pitchFamily="34" charset="-120"/>
+              </a:rPr>
+              <a:t> PC und spricht direkt mit den Daten.</a:t>
             </a:r>
             <a:endParaRPr lang="en-US" sz="1300" dirty="0"/>
           </a:p>
@@ -5628,7 +5650,7 @@
           <a:bodyPr/>
           <a:lstStyle/>
           <a:p>
-            <a:endParaRPr lang="de-DE"/>
+            <a:endParaRPr lang="de-DE" dirty="0"/>
           </a:p>
         </p:txBody>
       </p:sp>
@@ -5775,7 +5797,51 @@
                 <a:ea typeface="Calibri" pitchFamily="34" charset="-122"/>
                 <a:cs typeface="Calibri" pitchFamily="34" charset="-120"/>
               </a:rPr>
-              <a:t>Was wir zeigen:</a:t>
+              <a:t>Was </a:t>
+            </a:r>
+            <a:r>
+              <a:rPr lang="en-US" sz="1300" b="1" dirty="0" err="1">
+                <a:solidFill>
+                  <a:srgbClr val="1B3A6B"/>
+                </a:solidFill>
+                <a:latin typeface="Calibri" pitchFamily="34" charset="0"/>
+                <a:ea typeface="Calibri" pitchFamily="34" charset="-122"/>
+                <a:cs typeface="Calibri" pitchFamily="34" charset="-120"/>
+              </a:rPr>
+              <a:t>wir</a:t>
+            </a:r>
+            <a:r>
+              <a:rPr lang="en-US" sz="1300" b="1" dirty="0">
+                <a:solidFill>
+                  <a:srgbClr val="1B3A6B"/>
+                </a:solidFill>
+                <a:latin typeface="Calibri" pitchFamily="34" charset="0"/>
+                <a:ea typeface="Calibri" pitchFamily="34" charset="-122"/>
+                <a:cs typeface="Calibri" pitchFamily="34" charset="-120"/>
+              </a:rPr>
+              <a:t> </a:t>
+            </a:r>
+            <a:r>
+              <a:rPr lang="en-US" sz="1300" b="1" dirty="0" err="1">
+                <a:solidFill>
+                  <a:srgbClr val="1B3A6B"/>
+                </a:solidFill>
+                <a:latin typeface="Calibri" pitchFamily="34" charset="0"/>
+                <a:ea typeface="Calibri" pitchFamily="34" charset="-122"/>
+                <a:cs typeface="Calibri" pitchFamily="34" charset="-120"/>
+              </a:rPr>
+              <a:t>zeigen</a:t>
+            </a:r>
+            <a:r>
+              <a:rPr lang="en-US" sz="1300" b="1" dirty="0">
+                <a:solidFill>
+                  <a:srgbClr val="1B3A6B"/>
+                </a:solidFill>
+                <a:latin typeface="Calibri" pitchFamily="34" charset="0"/>
+                <a:ea typeface="Calibri" pitchFamily="34" charset="-122"/>
+                <a:cs typeface="Calibri" pitchFamily="34" charset="-120"/>
+              </a:rPr>
+              <a:t>:</a:t>
             </a:r>
             <a:endParaRPr lang="en-US" sz="1300" dirty="0"/>
           </a:p>
@@ -6197,8 +6263,38 @@
         </p:blipFill>
         <p:spPr>
           <a:xfrm>
-            <a:off x="-626098" y="-937234"/>
+            <a:off x="-617140" y="-937234"/>
             <a:ext cx="4731940" cy="3154627"/>
+          </a:xfrm>
+          <a:prstGeom prst="rect">
+            <a:avLst/>
+          </a:prstGeom>
+        </p:spPr>
+      </p:pic>
+      <p:pic>
+        <p:nvPicPr>
+          <p:cNvPr id="25" name="Grafik 24">
+            <a:extLst>
+              <a:ext uri="{FF2B5EF4-FFF2-40B4-BE49-F238E27FC236}">
+                <a16:creationId xmlns:a16="http://schemas.microsoft.com/office/drawing/2014/main" id="{30B4EDC4-29F6-7322-FBB1-1BF69194485E}"/>
+              </a:ext>
+            </a:extLst>
+          </p:cNvPr>
+          <p:cNvPicPr>
+            <a:picLocks noChangeAspect="1"/>
+          </p:cNvPicPr>
+          <p:nvPr/>
+        </p:nvPicPr>
+        <p:blipFill>
+          <a:blip r:embed="rId4"/>
+          <a:stretch>
+            <a:fillRect/>
+          </a:stretch>
+        </p:blipFill>
+        <p:spPr>
+          <a:xfrm>
+            <a:off x="589546" y="2399338"/>
+            <a:ext cx="7243011" cy="4045339"/>
           </a:xfrm>
           <a:prstGeom prst="rect">
             <a:avLst/>

</xml_diff>